<commit_message>
fix(vercel): add root index.html, vercel.json rewrite, and update standalone dashboard ablation benchmarks
</commit_message>
<xml_diff>
--- a/Amrita_SOC_Digital_Twin_Presentation_Final.pptx
+++ b/Amrita_SOC_Digital_Twin_Presentation_Final.pptx
@@ -128,6 +128,11 @@
       </a:defRPr>
     </a:lvl9pPr>
   </p:defaultTextStyle>
+  <p:extLst>
+    <p:ext uri="{EFAFB233-063F-42B5-8137-9DF3F51BA10A}">
+      <p15:sldGuideLst xmlns:p15="http://schemas.microsoft.com/office/powerpoint/2012/main"/>
+    </p:ext>
+  </p:extLst>
 </p:presentation>
 </file>
 
@@ -14887,7 +14892,7 @@
         <p:spPr>
           <a:xfrm>
             <a:off x="411480" y="685800"/>
-            <a:ext cx="9299520" cy="547920"/>
+            <a:ext cx="9299520" cy="384721"/>
           </a:xfrm>
           <a:prstGeom prst="rect">
             <a:avLst/>
@@ -14921,7 +14926,7 @@
               </a:lnSpc>
             </a:pPr>
             <a:r>
-              <a:rPr lang="en-US" sz="2500" b="1" u="none" strike="noStrike">
+              <a:rPr lang="en-US" sz="2500" b="1" u="none" strike="noStrike" dirty="0">
                 <a:solidFill>
                   <a:srgbClr val="831838"/>
                 </a:solidFill>
@@ -14929,20 +14934,9 @@
                 <a:uFillTx/>
                 <a:latin typeface="Poppins"/>
               </a:rPr>
-              <a:t>System Architecture  </a:t>
-            </a:r>
-            <a:r>
-              <a:rPr lang="en-US" sz="2500" b="0" u="none" strike="noStrike">
-                <a:solidFill>
-                  <a:srgbClr val="99A3AF"/>
-                </a:solidFill>
-                <a:effectLst/>
-                <a:uFillTx/>
-                <a:latin typeface="Poppins"/>
-              </a:rPr>
-              <a:t>Slide 07</a:t>
-            </a:r>
-            <a:endParaRPr lang="en-US" sz="2500" b="0" u="none" strike="noStrike">
+              <a:t>System Architecture</a:t>
+            </a:r>
+            <a:endParaRPr lang="en-US" sz="2500" b="0" u="none" strike="noStrike" dirty="0">
               <a:solidFill>
                 <a:srgbClr val="000000"/>
               </a:solidFill>
@@ -17161,7 +17155,7 @@
         <p:spPr>
           <a:xfrm>
             <a:off x="411480" y="685800"/>
-            <a:ext cx="9299520" cy="547920"/>
+            <a:ext cx="9299520" cy="384721"/>
           </a:xfrm>
           <a:prstGeom prst="rect">
             <a:avLst/>
@@ -17195,7 +17189,7 @@
               </a:lnSpc>
             </a:pPr>
             <a:r>
-              <a:rPr lang="en-US" sz="2500" b="1" u="none" strike="noStrike">
+              <a:rPr lang="en-US" sz="2500" b="1" u="none" strike="noStrike" dirty="0">
                 <a:solidFill>
                   <a:srgbClr val="831838"/>
                 </a:solidFill>
@@ -17203,20 +17197,9 @@
                 <a:uFillTx/>
                 <a:latin typeface="Poppins"/>
               </a:rPr>
-              <a:t>Dataset &amp; Data Preparation  </a:t>
-            </a:r>
-            <a:r>
-              <a:rPr lang="en-US" sz="2500" b="0" u="none" strike="noStrike">
-                <a:solidFill>
-                  <a:srgbClr val="99A3AF"/>
-                </a:solidFill>
-                <a:effectLst/>
-                <a:uFillTx/>
-                <a:latin typeface="Poppins"/>
-              </a:rPr>
-              <a:t>Slide 08</a:t>
-            </a:r>
-            <a:endParaRPr lang="en-US" sz="2500" b="0" u="none" strike="noStrike">
+              <a:t>Dataset &amp; Data Preparation</a:t>
+            </a:r>
+            <a:endParaRPr lang="en-US" sz="2500" b="0" u="none" strike="noStrike" dirty="0">
               <a:solidFill>
                 <a:srgbClr val="000000"/>
               </a:solidFill>
@@ -20549,7 +20532,7 @@
         <p:spPr>
           <a:xfrm>
             <a:off x="411480" y="685800"/>
-            <a:ext cx="9299520" cy="547920"/>
+            <a:ext cx="9299520" cy="384721"/>
           </a:xfrm>
           <a:prstGeom prst="rect">
             <a:avLst/>
@@ -20583,7 +20566,7 @@
               </a:lnSpc>
             </a:pPr>
             <a:r>
-              <a:rPr lang="en-US" sz="2500" b="1" u="none" strike="noStrike">
+              <a:rPr lang="en-US" sz="2500" b="1" u="none" strike="noStrike" dirty="0">
                 <a:solidFill>
                   <a:srgbClr val="831838"/>
                 </a:solidFill>
@@ -20591,20 +20574,9 @@
                 <a:uFillTx/>
                 <a:latin typeface="Poppins"/>
               </a:rPr>
-              <a:t>Feature Engineering  </a:t>
-            </a:r>
-            <a:r>
-              <a:rPr lang="en-US" sz="2500" b="0" u="none" strike="noStrike">
-                <a:solidFill>
-                  <a:srgbClr val="99A3AF"/>
-                </a:solidFill>
-                <a:effectLst/>
-                <a:uFillTx/>
-                <a:latin typeface="Poppins"/>
-              </a:rPr>
-              <a:t>Slide 09</a:t>
-            </a:r>
-            <a:endParaRPr lang="en-US" sz="2500" b="0" u="none" strike="noStrike">
+              <a:t>Feature Engineering</a:t>
+            </a:r>
+            <a:endParaRPr lang="en-US" sz="2500" b="0" u="none" strike="noStrike" dirty="0">
               <a:solidFill>
                 <a:srgbClr val="000000"/>
               </a:solidFill>
@@ -22478,7 +22450,7 @@
         <p:spPr>
           <a:xfrm>
             <a:off x="411480" y="685800"/>
-            <a:ext cx="9299520" cy="547920"/>
+            <a:ext cx="9299520" cy="384721"/>
           </a:xfrm>
           <a:prstGeom prst="rect">
             <a:avLst/>
@@ -22512,7 +22484,7 @@
               </a:lnSpc>
             </a:pPr>
             <a:r>
-              <a:rPr lang="en-US" sz="2500" b="1" u="none" strike="noStrike">
+              <a:rPr lang="en-US" sz="2500" b="1" u="none" strike="noStrike" dirty="0">
                 <a:solidFill>
                   <a:srgbClr val="831838"/>
                 </a:solidFill>
@@ -22520,20 +22492,9 @@
                 <a:uFillTx/>
                 <a:latin typeface="Poppins"/>
               </a:rPr>
-              <a:t>Model Architecture &amp; Ablations  </a:t>
-            </a:r>
-            <a:r>
-              <a:rPr lang="en-US" sz="2500" b="0" u="none" strike="noStrike">
-                <a:solidFill>
-                  <a:srgbClr val="99A3AF"/>
-                </a:solidFill>
-                <a:effectLst/>
-                <a:uFillTx/>
-                <a:latin typeface="Poppins"/>
-              </a:rPr>
-              <a:t>Slide 10</a:t>
-            </a:r>
-            <a:endParaRPr lang="en-US" sz="2500" b="0" u="none" strike="noStrike">
+              <a:t>Model Architecture &amp; Ablations</a:t>
+            </a:r>
+            <a:endParaRPr lang="en-US" sz="2500" b="0" u="none" strike="noStrike" dirty="0">
               <a:solidFill>
                 <a:srgbClr val="000000"/>
               </a:solidFill>
@@ -23256,7 +23217,7 @@
         <p:spPr>
           <a:xfrm>
             <a:off x="411480" y="685800"/>
-            <a:ext cx="9299520" cy="547920"/>
+            <a:ext cx="9299520" cy="384721"/>
           </a:xfrm>
           <a:prstGeom prst="rect">
             <a:avLst/>
@@ -23290,7 +23251,7 @@
               </a:lnSpc>
             </a:pPr>
             <a:r>
-              <a:rPr lang="en-US" sz="2500" b="1" u="none" strike="noStrike">
+              <a:rPr lang="en-US" sz="2500" b="1" u="none" strike="noStrike" dirty="0">
                 <a:solidFill>
                   <a:srgbClr val="831838"/>
                 </a:solidFill>
@@ -23298,20 +23259,9 @@
                 <a:uFillTx/>
                 <a:latin typeface="Poppins"/>
               </a:rPr>
-              <a:t>Multi-Algorithm Benchmark  </a:t>
-            </a:r>
-            <a:r>
-              <a:rPr lang="en-US" sz="2500" b="0" u="none" strike="noStrike">
-                <a:solidFill>
-                  <a:srgbClr val="99A3AF"/>
-                </a:solidFill>
-                <a:effectLst/>
-                <a:uFillTx/>
-                <a:latin typeface="Poppins"/>
-              </a:rPr>
-              <a:t>Slide 11</a:t>
-            </a:r>
-            <a:endParaRPr lang="en-US" sz="2500" b="0" u="none" strike="noStrike">
+              <a:t>Multi-Algorithm Benchmark</a:t>
+            </a:r>
+            <a:endParaRPr lang="en-US" sz="2500" b="0" u="none" strike="noStrike" dirty="0">
               <a:solidFill>
                 <a:srgbClr val="000000"/>
               </a:solidFill>
@@ -26617,7 +26567,7 @@
         <p:spPr>
           <a:xfrm>
             <a:off x="411480" y="685800"/>
-            <a:ext cx="9299520" cy="547920"/>
+            <a:ext cx="9299520" cy="384721"/>
           </a:xfrm>
           <a:prstGeom prst="rect">
             <a:avLst/>
@@ -26651,7 +26601,7 @@
               </a:lnSpc>
             </a:pPr>
             <a:r>
-              <a:rPr lang="en-US" sz="2500" b="1" u="none" strike="noStrike">
+              <a:rPr lang="en-US" sz="2500" b="1" u="none" strike="noStrike" dirty="0">
                 <a:solidFill>
                   <a:srgbClr val="831838"/>
                 </a:solidFill>
@@ -26659,20 +26609,9 @@
                 <a:uFillTx/>
                 <a:latin typeface="Poppins"/>
               </a:rPr>
-              <a:t>Results on Held-Out Cycles  </a:t>
-            </a:r>
-            <a:r>
-              <a:rPr lang="en-US" sz="2500" b="0" u="none" strike="noStrike">
-                <a:solidFill>
-                  <a:srgbClr val="99A3AF"/>
-                </a:solidFill>
-                <a:effectLst/>
-                <a:uFillTx/>
-                <a:latin typeface="Poppins"/>
-              </a:rPr>
-              <a:t>Slide 12</a:t>
-            </a:r>
-            <a:endParaRPr lang="en-US" sz="2500" b="0" u="none" strike="noStrike">
+              <a:t>Results on Held-Out Cycles</a:t>
+            </a:r>
+            <a:endParaRPr lang="en-US" sz="2500" b="0" u="none" strike="noStrike" dirty="0">
               <a:solidFill>
                 <a:srgbClr val="000000"/>
               </a:solidFill>
@@ -29217,7 +29156,7 @@
         <p:spPr>
           <a:xfrm>
             <a:off x="411480" y="685800"/>
-            <a:ext cx="9299520" cy="547920"/>
+            <a:ext cx="9299520" cy="384721"/>
           </a:xfrm>
           <a:prstGeom prst="rect">
             <a:avLst/>
@@ -29251,7 +29190,7 @@
               </a:lnSpc>
             </a:pPr>
             <a:r>
-              <a:rPr lang="en-US" sz="2500" b="1" u="none" strike="noStrike">
+              <a:rPr lang="en-US" sz="2500" b="1" u="none" strike="noStrike" dirty="0">
                 <a:solidFill>
                   <a:srgbClr val="831838"/>
                 </a:solidFill>
@@ -29259,20 +29198,9 @@
                 <a:uFillTx/>
                 <a:latin typeface="Poppins"/>
               </a:rPr>
-              <a:t>Sensor DC Bias &amp; Long-Horizon Drift  </a:t>
-            </a:r>
-            <a:r>
-              <a:rPr lang="en-US" sz="2500" b="0" u="none" strike="noStrike">
-                <a:solidFill>
-                  <a:srgbClr val="99A3AF"/>
-                </a:solidFill>
-                <a:effectLst/>
-                <a:uFillTx/>
-                <a:latin typeface="Poppins"/>
-              </a:rPr>
-              <a:t>Slide 13</a:t>
-            </a:r>
-            <a:endParaRPr lang="en-US" sz="2500" b="0" u="none" strike="noStrike">
+              <a:t>Sensor DC Bias &amp; Long-Horizon Drift</a:t>
+            </a:r>
+            <a:endParaRPr lang="en-US" sz="2500" b="0" u="none" strike="noStrike" dirty="0">
               <a:solidFill>
                 <a:srgbClr val="000000"/>
               </a:solidFill>
@@ -29834,7 +29762,7 @@
         <p:spPr>
           <a:xfrm>
             <a:off x="411480" y="685800"/>
-            <a:ext cx="9299520" cy="547920"/>
+            <a:ext cx="9299520" cy="384721"/>
           </a:xfrm>
           <a:prstGeom prst="rect">
             <a:avLst/>
@@ -29868,7 +29796,7 @@
               </a:lnSpc>
             </a:pPr>
             <a:r>
-              <a:rPr lang="en-US" sz="2500" b="1" u="none" strike="noStrike">
+              <a:rPr lang="en-US" sz="2500" b="1" u="none" strike="noStrike" dirty="0">
                 <a:solidFill>
                   <a:srgbClr val="831838"/>
                 </a:solidFill>
@@ -29876,20 +29804,9 @@
                 <a:uFillTx/>
                 <a:latin typeface="Poppins"/>
               </a:rPr>
-              <a:t>Hardware Robustness &amp; Stress Analysis  </a:t>
-            </a:r>
-            <a:r>
-              <a:rPr lang="en-US" sz="2500" b="0" u="none" strike="noStrike">
-                <a:solidFill>
-                  <a:srgbClr val="99A3AF"/>
-                </a:solidFill>
-                <a:effectLst/>
-                <a:uFillTx/>
-                <a:latin typeface="Poppins"/>
-              </a:rPr>
-              <a:t>Slide 14</a:t>
-            </a:r>
-            <a:endParaRPr lang="en-US" sz="2500" b="0" u="none" strike="noStrike">
+              <a:t>Hardware Robustness &amp; Stress Analysis</a:t>
+            </a:r>
+            <a:endParaRPr lang="en-US" sz="2500" b="0" u="none" strike="noStrike" dirty="0">
               <a:solidFill>
                 <a:srgbClr val="000000"/>
               </a:solidFill>
@@ -30525,7 +30442,7 @@
               </a:lnSpc>
             </a:pPr>
             <a:r>
-              <a:rPr lang="en-US" sz="2500" b="1" u="none" strike="noStrike">
+              <a:rPr lang="en-US" sz="2500" b="1" u="none" strike="noStrike" dirty="0">
                 <a:solidFill>
                   <a:srgbClr val="831838"/>
                 </a:solidFill>
@@ -30533,20 +30450,9 @@
                 <a:uFillTx/>
                 <a:latin typeface="Poppins"/>
               </a:rPr>
-              <a:t>Embedded Firmware Deployment  </a:t>
-            </a:r>
-            <a:r>
-              <a:rPr lang="en-US" sz="2500" b="0" u="none" strike="noStrike">
-                <a:solidFill>
-                  <a:srgbClr val="99A3AF"/>
-                </a:solidFill>
-                <a:effectLst/>
-                <a:uFillTx/>
-                <a:latin typeface="Poppins"/>
-              </a:rPr>
-              <a:t>Slide 15</a:t>
-            </a:r>
-            <a:endParaRPr lang="en-US" sz="2500" b="0" u="none" strike="noStrike">
+              <a:t>Embedded Firmware Deployment</a:t>
+            </a:r>
+            <a:endParaRPr lang="en-US" sz="2500" b="0" u="none" strike="noStrike" dirty="0">
               <a:solidFill>
                 <a:srgbClr val="000000"/>
               </a:solidFill>
@@ -32719,7 +32625,7 @@
               </a:lnSpc>
             </a:pPr>
             <a:r>
-              <a:rPr lang="en-US" sz="2500" b="1" u="none" strike="noStrike">
+              <a:rPr lang="en-US" sz="2500" b="1" u="none" strike="noStrike" dirty="0">
                 <a:solidFill>
                   <a:srgbClr val="831838"/>
                 </a:solidFill>
@@ -32727,20 +32633,9 @@
                 <a:uFillTx/>
                 <a:latin typeface="Poppins"/>
               </a:rPr>
-              <a:t>Digital Twin Web Dashboard  </a:t>
-            </a:r>
-            <a:r>
-              <a:rPr lang="en-US" sz="2500" b="0" u="none" strike="noStrike">
-                <a:solidFill>
-                  <a:srgbClr val="99A3AF"/>
-                </a:solidFill>
-                <a:effectLst/>
-                <a:uFillTx/>
-                <a:latin typeface="Poppins"/>
-              </a:rPr>
-              <a:t>Slide 16</a:t>
-            </a:r>
-            <a:endParaRPr lang="en-US" sz="2500" b="0" u="none" strike="noStrike">
+              <a:t>Digital Twin Web Dashboard</a:t>
+            </a:r>
+            <a:endParaRPr lang="en-US" sz="2500" b="0" u="none" strike="noStrike" dirty="0">
               <a:solidFill>
                 <a:srgbClr val="000000"/>
               </a:solidFill>
@@ -35595,7 +35490,7 @@
               </a:lnSpc>
             </a:pPr>
             <a:r>
-              <a:rPr lang="en-US" sz="2500" b="1" u="none" strike="noStrike">
+              <a:rPr lang="en-US" sz="2500" b="1" u="none" strike="noStrike" dirty="0">
                 <a:solidFill>
                   <a:srgbClr val="831838"/>
                 </a:solidFill>
@@ -35603,20 +35498,9 @@
                 <a:uFillTx/>
                 <a:latin typeface="Poppins"/>
               </a:rPr>
-              <a:t>Conclusion  </a:t>
-            </a:r>
-            <a:r>
-              <a:rPr lang="en-US" sz="2500" b="0" u="none" strike="noStrike">
-                <a:solidFill>
-                  <a:srgbClr val="99A3AF"/>
-                </a:solidFill>
-                <a:effectLst/>
-                <a:uFillTx/>
-                <a:latin typeface="Poppins"/>
-              </a:rPr>
-              <a:t>Slide 17</a:t>
-            </a:r>
-            <a:endParaRPr lang="en-US" sz="2500" b="0" u="none" strike="noStrike">
+              <a:t>Conclusion</a:t>
+            </a:r>
+            <a:endParaRPr lang="en-US" sz="2500" b="0" u="none" strike="noStrike" dirty="0">
               <a:solidFill>
                 <a:srgbClr val="000000"/>
               </a:solidFill>
@@ -36523,7 +36407,7 @@
               </a:lnSpc>
             </a:pPr>
             <a:r>
-              <a:rPr lang="en-US" sz="2500" b="1" u="none" strike="noStrike">
+              <a:rPr lang="en-US" sz="2500" b="1" u="none" strike="noStrike" dirty="0">
                 <a:solidFill>
                   <a:srgbClr val="831838"/>
                 </a:solidFill>
@@ -36531,20 +36415,9 @@
                 <a:uFillTx/>
                 <a:latin typeface="Poppins"/>
               </a:rPr>
-              <a:t>Future Scope &amp; Roadmap  </a:t>
-            </a:r>
-            <a:r>
-              <a:rPr lang="en-US" sz="2500" b="0" u="none" strike="noStrike">
-                <a:solidFill>
-                  <a:srgbClr val="99A3AF"/>
-                </a:solidFill>
-                <a:effectLst/>
-                <a:uFillTx/>
-                <a:latin typeface="Poppins"/>
-              </a:rPr>
-              <a:t>Slide 18</a:t>
-            </a:r>
-            <a:endParaRPr lang="en-US" sz="2500" b="0" u="none" strike="noStrike">
+              <a:t>Future Scope &amp; Roadmap</a:t>
+            </a:r>
+            <a:endParaRPr lang="en-US" sz="2500" b="0" u="none" strike="noStrike" dirty="0">
               <a:solidFill>
                 <a:srgbClr val="000000"/>
               </a:solidFill>
@@ -38466,7 +38339,7 @@
               </a:lnSpc>
             </a:pPr>
             <a:r>
-              <a:rPr lang="en-US" sz="2500" b="1" u="none" strike="noStrike">
+              <a:rPr lang="en-US" sz="2500" b="1" u="none" strike="noStrike" dirty="0">
                 <a:solidFill>
                   <a:srgbClr val="831838"/>
                 </a:solidFill>
@@ -38474,20 +38347,9 @@
                 <a:uFillTx/>
                 <a:latin typeface="Poppins"/>
               </a:rPr>
-              <a:t>References  </a:t>
-            </a:r>
-            <a:r>
-              <a:rPr lang="en-US" sz="2500" b="0" u="none" strike="noStrike">
-                <a:solidFill>
-                  <a:srgbClr val="99A3AF"/>
-                </a:solidFill>
-                <a:effectLst/>
-                <a:uFillTx/>
-                <a:latin typeface="Poppins"/>
-              </a:rPr>
-              <a:t>Slide 19</a:t>
-            </a:r>
-            <a:endParaRPr lang="en-US" sz="2500" b="0" u="none" strike="noStrike">
+              <a:t>References</a:t>
+            </a:r>
+            <a:endParaRPr lang="en-US" sz="2500" b="0" u="none" strike="noStrike" dirty="0">
               <a:solidFill>
                 <a:srgbClr val="000000"/>
               </a:solidFill>
@@ -39269,7 +39131,7 @@
         <p:spPr>
           <a:xfrm>
             <a:off x="411480" y="685800"/>
-            <a:ext cx="9299520" cy="547920"/>
+            <a:ext cx="9299520" cy="384721"/>
           </a:xfrm>
           <a:prstGeom prst="rect">
             <a:avLst/>
@@ -39303,7 +39165,7 @@
               </a:lnSpc>
             </a:pPr>
             <a:r>
-              <a:rPr lang="en-US" sz="2500" b="1" u="none" strike="noStrike">
+              <a:rPr lang="en-US" sz="2500" b="1" u="none" strike="noStrike" dirty="0">
                 <a:solidFill>
                   <a:srgbClr val="831838"/>
                 </a:solidFill>
@@ -39311,20 +39173,9 @@
                 <a:uFillTx/>
                 <a:latin typeface="Poppins"/>
               </a:rPr>
-              <a:t>Motivation  </a:t>
-            </a:r>
-            <a:r>
-              <a:rPr lang="en-US" sz="2500" b="0" u="none" strike="noStrike">
-                <a:solidFill>
-                  <a:srgbClr val="99A3AF"/>
-                </a:solidFill>
-                <a:effectLst/>
-                <a:uFillTx/>
-                <a:latin typeface="Poppins"/>
-              </a:rPr>
-              <a:t>Slide 01</a:t>
-            </a:r>
-            <a:endParaRPr lang="en-US" sz="2500" b="0" u="none" strike="noStrike">
+              <a:t>Motivation</a:t>
+            </a:r>
+            <a:endParaRPr lang="en-US" sz="2500" b="0" u="none" strike="noStrike" dirty="0">
               <a:solidFill>
                 <a:srgbClr val="000000"/>
               </a:solidFill>
@@ -40165,7 +40016,7 @@
         <p:spPr>
           <a:xfrm>
             <a:off x="411480" y="685800"/>
-            <a:ext cx="9299520" cy="547920"/>
+            <a:ext cx="9299520" cy="384721"/>
           </a:xfrm>
           <a:prstGeom prst="rect">
             <a:avLst/>
@@ -40199,7 +40050,7 @@
               </a:lnSpc>
             </a:pPr>
             <a:r>
-              <a:rPr lang="en-US" sz="2500" b="1" u="none" strike="noStrike">
+              <a:rPr lang="en-US" sz="2500" b="1" u="none" strike="noStrike" dirty="0">
                 <a:solidFill>
                   <a:srgbClr val="831838"/>
                 </a:solidFill>
@@ -40207,20 +40058,9 @@
                 <a:uFillTx/>
                 <a:latin typeface="Poppins"/>
               </a:rPr>
-              <a:t>Introduction  </a:t>
-            </a:r>
-            <a:r>
-              <a:rPr lang="en-US" sz="2500" b="0" u="none" strike="noStrike">
-                <a:solidFill>
-                  <a:srgbClr val="99A3AF"/>
-                </a:solidFill>
-                <a:effectLst/>
-                <a:uFillTx/>
-                <a:latin typeface="Poppins"/>
-              </a:rPr>
-              <a:t>Slide 02</a:t>
-            </a:r>
-            <a:endParaRPr lang="en-US" sz="2500" b="0" u="none" strike="noStrike">
+              <a:t>Introduction</a:t>
+            </a:r>
+            <a:endParaRPr lang="en-US" sz="2500" b="0" u="none" strike="noStrike" dirty="0">
               <a:solidFill>
                 <a:srgbClr val="000000"/>
               </a:solidFill>
@@ -40962,7 +40802,7 @@
         <p:spPr>
           <a:xfrm>
             <a:off x="7484400" y="3111480"/>
-            <a:ext cx="5092560" cy="245880"/>
+            <a:ext cx="3447105" cy="245880"/>
           </a:xfrm>
           <a:prstGeom prst="rect">
             <a:avLst/>
@@ -40985,7 +40825,7 @@
           <a:fontRef idx="minor"/>
         </p:style>
         <p:txBody>
-          <a:bodyPr lIns="0" tIns="0" rIns="0" bIns="0" anchor="t">
+          <a:bodyPr wrap="square" lIns="0" tIns="0" rIns="0" bIns="0" anchor="t">
             <a:spAutoFit/>
           </a:bodyPr>
           <a:lstStyle/>
@@ -40996,7 +40836,7 @@
               </a:lnSpc>
             </a:pPr>
             <a:r>
-              <a:rPr lang="en-US" sz="1600" b="1" u="none" strike="noStrike">
+              <a:rPr lang="en-US" sz="1600" b="1" u="none" strike="noStrike" dirty="0">
                 <a:solidFill>
                   <a:srgbClr val="831838"/>
                 </a:solidFill>
@@ -41006,7 +40846,7 @@
               </a:rPr>
               <a:t>Digital Twin Emulation Setup</a:t>
             </a:r>
-            <a:endParaRPr lang="en-US" sz="1600" b="0" u="none" strike="noStrike">
+            <a:endParaRPr lang="en-US" sz="1600" b="0" u="none" strike="noStrike" dirty="0">
               <a:solidFill>
                 <a:srgbClr val="000000"/>
               </a:solidFill>
@@ -41257,7 +41097,7 @@
         <p:spPr>
           <a:xfrm>
             <a:off x="411480" y="685800"/>
-            <a:ext cx="9299520" cy="547920"/>
+            <a:ext cx="9299520" cy="384721"/>
           </a:xfrm>
           <a:prstGeom prst="rect">
             <a:avLst/>
@@ -41291,7 +41131,7 @@
               </a:lnSpc>
             </a:pPr>
             <a:r>
-              <a:rPr lang="en-US" sz="2500" b="1" u="none" strike="noStrike">
+              <a:rPr lang="en-US" sz="2500" b="1" u="none" strike="noStrike" dirty="0">
                 <a:solidFill>
                   <a:srgbClr val="831838"/>
                 </a:solidFill>
@@ -41299,20 +41139,9 @@
                 <a:uFillTx/>
                 <a:latin typeface="Poppins"/>
               </a:rPr>
-              <a:t>State of the Art in Related Area  </a:t>
-            </a:r>
-            <a:r>
-              <a:rPr lang="en-US" sz="2500" b="0" u="none" strike="noStrike">
-                <a:solidFill>
-                  <a:srgbClr val="99A3AF"/>
-                </a:solidFill>
-                <a:effectLst/>
-                <a:uFillTx/>
-                <a:latin typeface="Poppins"/>
-              </a:rPr>
-              <a:t>Slide 03</a:t>
-            </a:r>
-            <a:endParaRPr lang="en-US" sz="2500" b="0" u="none" strike="noStrike">
+              <a:t>State of the Art in Related Area</a:t>
+            </a:r>
+            <a:endParaRPr lang="en-US" sz="2500" b="0" u="none" strike="noStrike" dirty="0">
               <a:solidFill>
                 <a:srgbClr val="000000"/>
               </a:solidFill>
@@ -42848,7 +42677,7 @@
         <p:spPr>
           <a:xfrm>
             <a:off x="411480" y="685800"/>
-            <a:ext cx="9299520" cy="547920"/>
+            <a:ext cx="9299520" cy="384721"/>
           </a:xfrm>
           <a:prstGeom prst="rect">
             <a:avLst/>
@@ -42882,7 +42711,7 @@
               </a:lnSpc>
             </a:pPr>
             <a:r>
-              <a:rPr lang="en-US" sz="2500" b="1" u="none" strike="noStrike">
+              <a:rPr lang="en-US" sz="2500" b="1" u="none" strike="noStrike" dirty="0">
                 <a:solidFill>
                   <a:srgbClr val="831838"/>
                 </a:solidFill>
@@ -42890,20 +42719,9 @@
                 <a:uFillTx/>
                 <a:latin typeface="Poppins"/>
               </a:rPr>
-              <a:t>Literature Review: Classical Methods  </a:t>
-            </a:r>
-            <a:r>
-              <a:rPr lang="en-US" sz="2500" b="0" u="none" strike="noStrike">
-                <a:solidFill>
-                  <a:srgbClr val="99A3AF"/>
-                </a:solidFill>
-                <a:effectLst/>
-                <a:uFillTx/>
-                <a:latin typeface="Poppins"/>
-              </a:rPr>
-              <a:t>Slide 04a</a:t>
-            </a:r>
-            <a:endParaRPr lang="en-US" sz="2500" b="0" u="none" strike="noStrike">
+              <a:t>Literature Review: Classical Methods</a:t>
+            </a:r>
+            <a:endParaRPr lang="en-US" sz="2500" b="0" u="none" strike="noStrike" dirty="0">
               <a:solidFill>
                 <a:srgbClr val="000000"/>
               </a:solidFill>
@@ -44414,7 +44232,7 @@
         <p:spPr>
           <a:xfrm>
             <a:off x="411480" y="685800"/>
-            <a:ext cx="9299520" cy="547920"/>
+            <a:ext cx="9299520" cy="384721"/>
           </a:xfrm>
           <a:prstGeom prst="rect">
             <a:avLst/>
@@ -44448,7 +44266,7 @@
               </a:lnSpc>
             </a:pPr>
             <a:r>
-              <a:rPr lang="en-US" sz="2500" b="1" u="none" strike="noStrike">
+              <a:rPr lang="en-US" sz="2500" b="1" u="none" strike="noStrike" dirty="0">
                 <a:solidFill>
                   <a:srgbClr val="831838"/>
                 </a:solidFill>
@@ -44456,20 +44274,9 @@
                 <a:uFillTx/>
                 <a:latin typeface="Poppins"/>
               </a:rPr>
-              <a:t>Literature Review: AI &amp; Hybrid Frameworks  </a:t>
-            </a:r>
-            <a:r>
-              <a:rPr lang="en-US" sz="2500" b="0" u="none" strike="noStrike">
-                <a:solidFill>
-                  <a:srgbClr val="99A3AF"/>
-                </a:solidFill>
-                <a:effectLst/>
-                <a:uFillTx/>
-                <a:latin typeface="Poppins"/>
-              </a:rPr>
-              <a:t>Slide 04b</a:t>
-            </a:r>
-            <a:endParaRPr lang="en-US" sz="2500" b="0" u="none" strike="noStrike">
+              <a:t>Literature Review: AI &amp; Hybrid Frameworks</a:t>
+            </a:r>
+            <a:endParaRPr lang="en-US" sz="2500" b="0" u="none" strike="noStrike" dirty="0">
               <a:solidFill>
                 <a:srgbClr val="000000"/>
               </a:solidFill>
@@ -45641,7 +45448,7 @@
         <p:spPr>
           <a:xfrm>
             <a:off x="411480" y="685800"/>
-            <a:ext cx="9299520" cy="547920"/>
+            <a:ext cx="9299520" cy="384721"/>
           </a:xfrm>
           <a:prstGeom prst="rect">
             <a:avLst/>
@@ -45675,7 +45482,7 @@
               </a:lnSpc>
             </a:pPr>
             <a:r>
-              <a:rPr lang="en-US" sz="2500" b="1" u="none" strike="noStrike">
+              <a:rPr lang="en-US" sz="2500" b="1" u="none" strike="noStrike" dirty="0">
                 <a:solidFill>
                   <a:srgbClr val="831838"/>
                 </a:solidFill>
@@ -45683,20 +45490,9 @@
                 <a:uFillTx/>
                 <a:latin typeface="Poppins"/>
               </a:rPr>
-              <a:t>Project Objective  </a:t>
-            </a:r>
-            <a:r>
-              <a:rPr lang="en-US" sz="2500" b="0" u="none" strike="noStrike">
-                <a:solidFill>
-                  <a:srgbClr val="99A3AF"/>
-                </a:solidFill>
-                <a:effectLst/>
-                <a:uFillTx/>
-                <a:latin typeface="Poppins"/>
-              </a:rPr>
-              <a:t>Slide 05</a:t>
-            </a:r>
-            <a:endParaRPr lang="en-US" sz="2500" b="0" u="none" strike="noStrike">
+              <a:t>Project Objective</a:t>
+            </a:r>
+            <a:endParaRPr lang="en-US" sz="2500" b="0" u="none" strike="noStrike" dirty="0">
               <a:solidFill>
                 <a:srgbClr val="000000"/>
               </a:solidFill>
@@ -47241,7 +47037,7 @@
         <p:spPr>
           <a:xfrm>
             <a:off x="411480" y="685800"/>
-            <a:ext cx="9299520" cy="547920"/>
+            <a:ext cx="9299520" cy="384721"/>
           </a:xfrm>
           <a:prstGeom prst="rect">
             <a:avLst/>
@@ -47275,7 +47071,7 @@
               </a:lnSpc>
             </a:pPr>
             <a:r>
-              <a:rPr lang="en-US" sz="2500" b="1" u="none" strike="noStrike">
+              <a:rPr lang="en-US" sz="2500" b="1" u="none" strike="noStrike" dirty="0">
                 <a:solidFill>
                   <a:srgbClr val="831838"/>
                 </a:solidFill>
@@ -47283,20 +47079,9 @@
                 <a:uFillTx/>
                 <a:latin typeface="Poppins"/>
               </a:rPr>
-              <a:t>Methodology  </a:t>
-            </a:r>
-            <a:r>
-              <a:rPr lang="en-US" sz="2500" b="0" u="none" strike="noStrike">
-                <a:solidFill>
-                  <a:srgbClr val="99A3AF"/>
-                </a:solidFill>
-                <a:effectLst/>
-                <a:uFillTx/>
-                <a:latin typeface="Poppins"/>
-              </a:rPr>
-              <a:t>Slide 06</a:t>
-            </a:r>
-            <a:endParaRPr lang="en-US" sz="2500" b="0" u="none" strike="noStrike">
+              <a:t>Methodology</a:t>
+            </a:r>
+            <a:endParaRPr lang="en-US" sz="2500" b="0" u="none" strike="noStrike" dirty="0">
               <a:solidFill>
                 <a:srgbClr val="000000"/>
               </a:solidFill>

</xml_diff>